<commit_message>
Restyle workshop and cheatsheet with white and Maroo core colors
</commit_message>
<xml_diff>
--- a/video/Video_Slides.pptx
+++ b/video/Video_Slides.pptx
@@ -3984,7 +3984,7 @@
             <a:avLst/>
           </a:prstGeom>
           <a:solidFill>
-            <a:srgbClr val="101B2D"/>
+            <a:srgbClr val="FFFFFF"/>
           </a:solidFill>
           <a:ln>
             <a:noFill/>
@@ -4027,7 +4027,7 @@
             <a:avLst/>
           </a:prstGeom>
           <a:solidFill>
-            <a:srgbClr val="58D6BD"/>
+            <a:srgbClr val="007A8A"/>
           </a:solidFill>
           <a:ln>
             <a:noFill/>
@@ -4080,7 +4080,7 @@
             <a:pPr>
               <a:defRPr sz="1200" b="1">
                 <a:solidFill>
-                  <a:srgbClr val="58D6BD"/>
+                  <a:srgbClr val="007A8A"/>
                 </a:solidFill>
                 <a:latin typeface="맑은 고딕"/>
               </a:defRPr>
@@ -4116,7 +4116,7 @@
             <a:pPr>
               <a:defRPr sz="1200" b="0">
                 <a:solidFill>
-                  <a:srgbClr val="A9BAD0"/>
+                  <a:srgbClr val="5C747B"/>
                 </a:solidFill>
                 <a:latin typeface="맑은 고딕"/>
               </a:defRPr>
@@ -4152,7 +4152,7 @@
             <a:pPr>
               <a:defRPr sz="3200" b="1">
                 <a:solidFill>
-                  <a:srgbClr val="F3F6FA"/>
+                  <a:srgbClr val="16343B"/>
                 </a:solidFill>
                 <a:latin typeface="맑은 고딕"/>
               </a:defRPr>
@@ -4188,7 +4188,7 @@
             <a:pPr>
               <a:defRPr sz="1900" b="0">
                 <a:solidFill>
-                  <a:srgbClr val="A9BAD0"/>
+                  <a:srgbClr val="5C747B"/>
                 </a:solidFill>
                 <a:latin typeface="맑은 고딕"/>
               </a:defRPr>
@@ -4201,7 +4201,7 @@
       </p:sp>
       <p:sp>
         <p:nvSpPr>
-          <p:cNvPr id="8" name="Rectangle 7"/>
+          <p:cNvPr id="8" name="Rounded Rectangle 7"/>
           <p:cNvSpPr/>
           <p:nvPr/>
         </p:nvSpPr>
@@ -4210,11 +4210,11 @@
             <a:off x="640080" y="3182112"/>
             <a:ext cx="3529584" cy="2194560"/>
           </a:xfrm>
-          <a:prstGeom prst="rect">
+          <a:prstGeom prst="roundRect">
             <a:avLst/>
           </a:prstGeom>
           <a:solidFill>
-            <a:srgbClr val="1A2A40"/>
+            <a:srgbClr val="EAF7F9"/>
           </a:solidFill>
           <a:ln>
             <a:noFill/>
@@ -4257,7 +4257,7 @@
             <a:avLst/>
           </a:prstGeom>
           <a:solidFill>
-            <a:srgbClr val="58D6BD"/>
+            <a:srgbClr val="007A8A"/>
           </a:solidFill>
           <a:ln>
             <a:noFill/>
@@ -4300,7 +4300,7 @@
             <a:avLst/>
           </a:prstGeom>
           <a:solidFill>
-            <a:srgbClr val="58D6BD"/>
+            <a:srgbClr val="007A8A"/>
           </a:solidFill>
           <a:ln>
             <a:noFill/>
@@ -4353,7 +4353,7 @@
             <a:pPr>
               <a:defRPr sz="1700" b="1">
                 <a:solidFill>
-                  <a:srgbClr val="58D6BD"/>
+                  <a:srgbClr val="007A8A"/>
                 </a:solidFill>
                 <a:latin typeface="맑은 고딕"/>
               </a:defRPr>
@@ -4389,7 +4389,7 @@
             <a:pPr>
               <a:defRPr sz="1800" b="0">
                 <a:solidFill>
-                  <a:srgbClr val="F3F6FA"/>
+                  <a:srgbClr val="16343B"/>
                 </a:solidFill>
                 <a:latin typeface="맑은 고딕"/>
               </a:defRPr>
@@ -4402,7 +4402,7 @@
             <a:pPr>
               <a:defRPr sz="1800" b="0">
                 <a:solidFill>
-                  <a:srgbClr val="F3F6FA"/>
+                  <a:srgbClr val="16343B"/>
                 </a:solidFill>
                 <a:latin typeface="맑은 고딕"/>
               </a:defRPr>
@@ -4415,7 +4415,7 @@
       </p:sp>
       <p:sp>
         <p:nvSpPr>
-          <p:cNvPr id="13" name="Rectangle 12"/>
+          <p:cNvPr id="13" name="Rounded Rectangle 12"/>
           <p:cNvSpPr/>
           <p:nvPr/>
         </p:nvSpPr>
@@ -4424,11 +4424,11 @@
             <a:off x="4325112" y="3182112"/>
             <a:ext cx="3529584" cy="2194560"/>
           </a:xfrm>
-          <a:prstGeom prst="rect">
+          <a:prstGeom prst="roundRect">
             <a:avLst/>
           </a:prstGeom>
           <a:solidFill>
-            <a:srgbClr val="1A2A40"/>
+            <a:srgbClr val="EAF7F9"/>
           </a:solidFill>
           <a:ln>
             <a:noFill/>
@@ -4471,7 +4471,7 @@
             <a:avLst/>
           </a:prstGeom>
           <a:solidFill>
-            <a:srgbClr val="58D6BD"/>
+            <a:srgbClr val="007A8A"/>
           </a:solidFill>
           <a:ln>
             <a:noFill/>
@@ -4514,7 +4514,7 @@
             <a:avLst/>
           </a:prstGeom>
           <a:solidFill>
-            <a:srgbClr val="FFBD69"/>
+            <a:srgbClr val="AC4A18"/>
           </a:solidFill>
           <a:ln>
             <a:noFill/>
@@ -4567,7 +4567,7 @@
             <a:pPr>
               <a:defRPr sz="1700" b="1">
                 <a:solidFill>
-                  <a:srgbClr val="FFBD69"/>
+                  <a:srgbClr val="AC4A18"/>
                 </a:solidFill>
                 <a:latin typeface="맑은 고딕"/>
               </a:defRPr>
@@ -4603,7 +4603,7 @@
             <a:pPr>
               <a:defRPr sz="1800" b="0">
                 <a:solidFill>
-                  <a:srgbClr val="F3F6FA"/>
+                  <a:srgbClr val="16343B"/>
                 </a:solidFill>
                 <a:latin typeface="맑은 고딕"/>
               </a:defRPr>
@@ -4616,7 +4616,7 @@
       </p:sp>
       <p:sp>
         <p:nvSpPr>
-          <p:cNvPr id="18" name="Rectangle 17"/>
+          <p:cNvPr id="18" name="Rounded Rectangle 17"/>
           <p:cNvSpPr/>
           <p:nvPr/>
         </p:nvSpPr>
@@ -4625,11 +4625,11 @@
             <a:off x="8010144" y="3182112"/>
             <a:ext cx="3529584" cy="2194560"/>
           </a:xfrm>
-          <a:prstGeom prst="rect">
+          <a:prstGeom prst="roundRect">
             <a:avLst/>
           </a:prstGeom>
           <a:solidFill>
-            <a:srgbClr val="1A2A40"/>
+            <a:srgbClr val="EAF7F9"/>
           </a:solidFill>
           <a:ln>
             <a:noFill/>
@@ -4672,7 +4672,7 @@
             <a:avLst/>
           </a:prstGeom>
           <a:solidFill>
-            <a:srgbClr val="58D6BD"/>
+            <a:srgbClr val="007A8A"/>
           </a:solidFill>
           <a:ln>
             <a:noFill/>
@@ -4715,7 +4715,7 @@
             <a:avLst/>
           </a:prstGeom>
           <a:solidFill>
-            <a:srgbClr val="BDABFF"/>
+            <a:srgbClr val="007A8A"/>
           </a:solidFill>
           <a:ln>
             <a:noFill/>
@@ -4768,7 +4768,7 @@
             <a:pPr>
               <a:defRPr sz="1700" b="1">
                 <a:solidFill>
-                  <a:srgbClr val="BDABFF"/>
+                  <a:srgbClr val="007A8A"/>
                 </a:solidFill>
                 <a:latin typeface="맑은 고딕"/>
               </a:defRPr>
@@ -4804,7 +4804,7 @@
             <a:pPr>
               <a:defRPr sz="1800" b="0">
                 <a:solidFill>
-                  <a:srgbClr val="F3F6FA"/>
+                  <a:srgbClr val="16343B"/>
                 </a:solidFill>
                 <a:latin typeface="맑은 고딕"/>
               </a:defRPr>
@@ -4817,7 +4817,7 @@
             <a:pPr>
               <a:defRPr sz="1800" b="0">
                 <a:solidFill>
-                  <a:srgbClr val="F3F6FA"/>
+                  <a:srgbClr val="16343B"/>
                 </a:solidFill>
                 <a:latin typeface="맑은 고딕"/>
               </a:defRPr>
@@ -4853,7 +4853,7 @@
             <a:pPr>
               <a:defRPr sz="1200" b="0">
                 <a:solidFill>
-                  <a:srgbClr val="A9BAD0"/>
+                  <a:srgbClr val="5C747B"/>
                 </a:solidFill>
                 <a:latin typeface="맑은 고딕"/>
               </a:defRPr>
@@ -4879,7 +4879,7 @@
             <a:avLst/>
           </a:prstGeom>
           <a:solidFill>
-            <a:srgbClr val="1A2A40"/>
+            <a:srgbClr val="EAF7F9"/>
           </a:solidFill>
           <a:ln>
             <a:noFill/>
@@ -4922,7 +4922,7 @@
             <a:avLst/>
           </a:prstGeom>
           <a:solidFill>
-            <a:srgbClr val="58D6BD"/>
+            <a:srgbClr val="007A8A"/>
           </a:solidFill>
           <a:ln>
             <a:noFill/>
@@ -4975,7 +4975,7 @@
             <a:pPr>
               <a:defRPr sz="900" b="0">
                 <a:solidFill>
-                  <a:srgbClr val="A9BAD0"/>
+                  <a:srgbClr val="5C747B"/>
                 </a:solidFill>
                 <a:latin typeface="맑은 고딕"/>
               </a:defRPr>
@@ -5011,7 +5011,7 @@
             <a:pPr>
               <a:defRPr sz="1000" b="0">
                 <a:solidFill>
-                  <a:srgbClr val="A9BAD0"/>
+                  <a:srgbClr val="5C747B"/>
                 </a:solidFill>
                 <a:latin typeface="맑은 고딕"/>
               </a:defRPr>
@@ -5055,7 +5055,7 @@
             <a:avLst/>
           </a:prstGeom>
           <a:solidFill>
-            <a:srgbClr val="101B2D"/>
+            <a:srgbClr val="FFFFFF"/>
           </a:solidFill>
           <a:ln>
             <a:noFill/>
@@ -5098,7 +5098,7 @@
             <a:avLst/>
           </a:prstGeom>
           <a:solidFill>
-            <a:srgbClr val="58D6BD"/>
+            <a:srgbClr val="007A8A"/>
           </a:solidFill>
           <a:ln>
             <a:noFill/>
@@ -5151,7 +5151,7 @@
             <a:pPr>
               <a:defRPr sz="1200" b="1">
                 <a:solidFill>
-                  <a:srgbClr val="58D6BD"/>
+                  <a:srgbClr val="007A8A"/>
                 </a:solidFill>
                 <a:latin typeface="맑은 고딕"/>
               </a:defRPr>
@@ -5187,7 +5187,7 @@
             <a:pPr>
               <a:defRPr sz="1200" b="0">
                 <a:solidFill>
-                  <a:srgbClr val="A9BAD0"/>
+                  <a:srgbClr val="5C747B"/>
                 </a:solidFill>
                 <a:latin typeface="맑은 고딕"/>
               </a:defRPr>
@@ -5223,7 +5223,7 @@
             <a:pPr>
               <a:defRPr sz="3200" b="1">
                 <a:solidFill>
-                  <a:srgbClr val="F3F6FA"/>
+                  <a:srgbClr val="16343B"/>
                 </a:solidFill>
                 <a:latin typeface="맑은 고딕"/>
               </a:defRPr>
@@ -5259,7 +5259,7 @@
             <a:pPr>
               <a:defRPr sz="1900" b="0">
                 <a:solidFill>
-                  <a:srgbClr val="A9BAD0"/>
+                  <a:srgbClr val="5C747B"/>
                 </a:solidFill>
                 <a:latin typeface="맑은 고딕"/>
               </a:defRPr>
@@ -5272,7 +5272,7 @@
       </p:sp>
       <p:sp>
         <p:nvSpPr>
-          <p:cNvPr id="8" name="Rectangle 7"/>
+          <p:cNvPr id="8" name="Rounded Rectangle 7"/>
           <p:cNvSpPr/>
           <p:nvPr/>
         </p:nvSpPr>
@@ -5281,11 +5281,11 @@
             <a:off x="640080" y="3182112"/>
             <a:ext cx="3529584" cy="2194560"/>
           </a:xfrm>
-          <a:prstGeom prst="rect">
+          <a:prstGeom prst="roundRect">
             <a:avLst/>
           </a:prstGeom>
           <a:solidFill>
-            <a:srgbClr val="1A2A40"/>
+            <a:srgbClr val="EAF7F9"/>
           </a:solidFill>
           <a:ln>
             <a:noFill/>
@@ -5328,7 +5328,7 @@
             <a:avLst/>
           </a:prstGeom>
           <a:solidFill>
-            <a:srgbClr val="58D6BD"/>
+            <a:srgbClr val="007A8A"/>
           </a:solidFill>
           <a:ln>
             <a:noFill/>
@@ -5371,7 +5371,7 @@
             <a:avLst/>
           </a:prstGeom>
           <a:solidFill>
-            <a:srgbClr val="58D6BD"/>
+            <a:srgbClr val="007A8A"/>
           </a:solidFill>
           <a:ln>
             <a:noFill/>
@@ -5424,7 +5424,7 @@
             <a:pPr>
               <a:defRPr sz="1700" b="1">
                 <a:solidFill>
-                  <a:srgbClr val="58D6BD"/>
+                  <a:srgbClr val="007A8A"/>
                 </a:solidFill>
                 <a:latin typeface="맑은 고딕"/>
               </a:defRPr>
@@ -5460,7 +5460,7 @@
             <a:pPr>
               <a:defRPr sz="1800" b="0">
                 <a:solidFill>
-                  <a:srgbClr val="F3F6FA"/>
+                  <a:srgbClr val="16343B"/>
                 </a:solidFill>
                 <a:latin typeface="맑은 고딕"/>
               </a:defRPr>
@@ -5473,7 +5473,7 @@
       </p:sp>
       <p:sp>
         <p:nvSpPr>
-          <p:cNvPr id="13" name="Rectangle 12"/>
+          <p:cNvPr id="13" name="Rounded Rectangle 12"/>
           <p:cNvSpPr/>
           <p:nvPr/>
         </p:nvSpPr>
@@ -5482,11 +5482,11 @@
             <a:off x="4325112" y="3182112"/>
             <a:ext cx="3529584" cy="2194560"/>
           </a:xfrm>
-          <a:prstGeom prst="rect">
+          <a:prstGeom prst="roundRect">
             <a:avLst/>
           </a:prstGeom>
           <a:solidFill>
-            <a:srgbClr val="1A2A40"/>
+            <a:srgbClr val="EAF7F9"/>
           </a:solidFill>
           <a:ln>
             <a:noFill/>
@@ -5529,7 +5529,7 @@
             <a:avLst/>
           </a:prstGeom>
           <a:solidFill>
-            <a:srgbClr val="58D6BD"/>
+            <a:srgbClr val="007A8A"/>
           </a:solidFill>
           <a:ln>
             <a:noFill/>
@@ -5572,7 +5572,7 @@
             <a:avLst/>
           </a:prstGeom>
           <a:solidFill>
-            <a:srgbClr val="58D6BD"/>
+            <a:srgbClr val="007A8A"/>
           </a:solidFill>
           <a:ln>
             <a:noFill/>
@@ -5625,7 +5625,7 @@
             <a:pPr>
               <a:defRPr sz="1700" b="1">
                 <a:solidFill>
-                  <a:srgbClr val="58D6BD"/>
+                  <a:srgbClr val="007A8A"/>
                 </a:solidFill>
                 <a:latin typeface="맑은 고딕"/>
               </a:defRPr>
@@ -5661,7 +5661,7 @@
             <a:pPr>
               <a:defRPr sz="1800" b="0">
                 <a:solidFill>
-                  <a:srgbClr val="F3F6FA"/>
+                  <a:srgbClr val="16343B"/>
                 </a:solidFill>
                 <a:latin typeface="맑은 고딕"/>
               </a:defRPr>
@@ -5674,7 +5674,7 @@
       </p:sp>
       <p:sp>
         <p:nvSpPr>
-          <p:cNvPr id="18" name="Rectangle 17"/>
+          <p:cNvPr id="18" name="Rounded Rectangle 17"/>
           <p:cNvSpPr/>
           <p:nvPr/>
         </p:nvSpPr>
@@ -5683,11 +5683,11 @@
             <a:off x="8010144" y="3182112"/>
             <a:ext cx="3529584" cy="2194560"/>
           </a:xfrm>
-          <a:prstGeom prst="rect">
+          <a:prstGeom prst="roundRect">
             <a:avLst/>
           </a:prstGeom>
           <a:solidFill>
-            <a:srgbClr val="1A2A40"/>
+            <a:srgbClr val="EAF7F9"/>
           </a:solidFill>
           <a:ln>
             <a:noFill/>
@@ -5730,7 +5730,7 @@
             <a:avLst/>
           </a:prstGeom>
           <a:solidFill>
-            <a:srgbClr val="58D6BD"/>
+            <a:srgbClr val="007A8A"/>
           </a:solidFill>
           <a:ln>
             <a:noFill/>
@@ -5773,7 +5773,7 @@
             <a:avLst/>
           </a:prstGeom>
           <a:solidFill>
-            <a:srgbClr val="58D6BD"/>
+            <a:srgbClr val="007A8A"/>
           </a:solidFill>
           <a:ln>
             <a:noFill/>
@@ -5826,7 +5826,7 @@
             <a:pPr>
               <a:defRPr sz="1700" b="1">
                 <a:solidFill>
-                  <a:srgbClr val="58D6BD"/>
+                  <a:srgbClr val="007A8A"/>
                 </a:solidFill>
                 <a:latin typeface="맑은 고딕"/>
               </a:defRPr>
@@ -5862,7 +5862,7 @@
             <a:pPr>
               <a:defRPr sz="1800" b="0">
                 <a:solidFill>
-                  <a:srgbClr val="F3F6FA"/>
+                  <a:srgbClr val="16343B"/>
                 </a:solidFill>
                 <a:latin typeface="맑은 고딕"/>
               </a:defRPr>
@@ -5888,7 +5888,7 @@
             <a:avLst/>
           </a:prstGeom>
           <a:solidFill>
-            <a:srgbClr val="101B2D"/>
+            <a:srgbClr val="FFFFFF"/>
           </a:solidFill>
           <a:ln>
             <a:noFill/>
@@ -5941,7 +5941,7 @@
             <a:pPr>
               <a:defRPr sz="2300" b="1">
                 <a:solidFill>
-                  <a:srgbClr val="58D6BD"/>
+                  <a:srgbClr val="007A8A"/>
                 </a:solidFill>
                 <a:latin typeface="맑은 고딕"/>
               </a:defRPr>
@@ -5967,7 +5967,7 @@
             <a:avLst/>
           </a:prstGeom>
           <a:solidFill>
-            <a:srgbClr val="101B2D"/>
+            <a:srgbClr val="FFFFFF"/>
           </a:solidFill>
           <a:ln>
             <a:noFill/>
@@ -6020,7 +6020,7 @@
             <a:pPr>
               <a:defRPr sz="2300" b="1">
                 <a:solidFill>
-                  <a:srgbClr val="58D6BD"/>
+                  <a:srgbClr val="007A8A"/>
                 </a:solidFill>
                 <a:latin typeface="맑은 고딕"/>
               </a:defRPr>
@@ -6056,7 +6056,7 @@
             <a:pPr>
               <a:defRPr sz="1200" b="0">
                 <a:solidFill>
-                  <a:srgbClr val="A9BAD0"/>
+                  <a:srgbClr val="5C747B"/>
                 </a:solidFill>
                 <a:latin typeface="맑은 고딕"/>
               </a:defRPr>
@@ -6082,7 +6082,7 @@
             <a:avLst/>
           </a:prstGeom>
           <a:solidFill>
-            <a:srgbClr val="1A2A40"/>
+            <a:srgbClr val="EAF7F9"/>
           </a:solidFill>
           <a:ln>
             <a:noFill/>
@@ -6125,7 +6125,7 @@
             <a:avLst/>
           </a:prstGeom>
           <a:solidFill>
-            <a:srgbClr val="58D6BD"/>
+            <a:srgbClr val="007A8A"/>
           </a:solidFill>
           <a:ln>
             <a:noFill/>
@@ -6178,7 +6178,7 @@
             <a:pPr>
               <a:defRPr sz="900" b="0">
                 <a:solidFill>
-                  <a:srgbClr val="A9BAD0"/>
+                  <a:srgbClr val="5C747B"/>
                 </a:solidFill>
                 <a:latin typeface="맑은 고딕"/>
               </a:defRPr>
@@ -6214,7 +6214,7 @@
             <a:pPr>
               <a:defRPr sz="1000" b="0">
                 <a:solidFill>
-                  <a:srgbClr val="A9BAD0"/>
+                  <a:srgbClr val="5C747B"/>
                 </a:solidFill>
                 <a:latin typeface="맑은 고딕"/>
               </a:defRPr>
@@ -6258,7 +6258,7 @@
             <a:avLst/>
           </a:prstGeom>
           <a:solidFill>
-            <a:srgbClr val="101B2D"/>
+            <a:srgbClr val="FFFFFF"/>
           </a:solidFill>
           <a:ln>
             <a:noFill/>
@@ -6301,7 +6301,7 @@
             <a:avLst/>
           </a:prstGeom>
           <a:solidFill>
-            <a:srgbClr val="58D6BD"/>
+            <a:srgbClr val="007A8A"/>
           </a:solidFill>
           <a:ln>
             <a:noFill/>
@@ -6354,7 +6354,7 @@
             <a:pPr>
               <a:defRPr sz="1200" b="1">
                 <a:solidFill>
-                  <a:srgbClr val="58D6BD"/>
+                  <a:srgbClr val="007A8A"/>
                 </a:solidFill>
                 <a:latin typeface="맑은 고딕"/>
               </a:defRPr>
@@ -6390,7 +6390,7 @@
             <a:pPr>
               <a:defRPr sz="1200" b="0">
                 <a:solidFill>
-                  <a:srgbClr val="A9BAD0"/>
+                  <a:srgbClr val="5C747B"/>
                 </a:solidFill>
                 <a:latin typeface="맑은 고딕"/>
               </a:defRPr>
@@ -6426,7 +6426,7 @@
             <a:pPr>
               <a:defRPr sz="3200" b="1">
                 <a:solidFill>
-                  <a:srgbClr val="F3F6FA"/>
+                  <a:srgbClr val="16343B"/>
                 </a:solidFill>
                 <a:latin typeface="맑은 고딕"/>
               </a:defRPr>
@@ -6462,7 +6462,7 @@
             <a:pPr>
               <a:defRPr sz="1900" b="0">
                 <a:solidFill>
-                  <a:srgbClr val="A9BAD0"/>
+                  <a:srgbClr val="5C747B"/>
                 </a:solidFill>
                 <a:latin typeface="맑은 고딕"/>
               </a:defRPr>
@@ -6475,7 +6475,7 @@
       </p:sp>
       <p:sp>
         <p:nvSpPr>
-          <p:cNvPr id="8" name="Rectangle 7"/>
+          <p:cNvPr id="8" name="Rounded Rectangle 7"/>
           <p:cNvSpPr/>
           <p:nvPr/>
         </p:nvSpPr>
@@ -6484,11 +6484,11 @@
             <a:off x="640080" y="3182112"/>
             <a:ext cx="3529584" cy="2194560"/>
           </a:xfrm>
-          <a:prstGeom prst="rect">
+          <a:prstGeom prst="roundRect">
             <a:avLst/>
           </a:prstGeom>
           <a:solidFill>
-            <a:srgbClr val="1A2A40"/>
+            <a:srgbClr val="EAF7F9"/>
           </a:solidFill>
           <a:ln>
             <a:noFill/>
@@ -6531,7 +6531,7 @@
             <a:avLst/>
           </a:prstGeom>
           <a:solidFill>
-            <a:srgbClr val="58D6BD"/>
+            <a:srgbClr val="007A8A"/>
           </a:solidFill>
           <a:ln>
             <a:noFill/>
@@ -6574,7 +6574,7 @@
             <a:avLst/>
           </a:prstGeom>
           <a:solidFill>
-            <a:srgbClr val="58D6BD"/>
+            <a:srgbClr val="007A8A"/>
           </a:solidFill>
           <a:ln>
             <a:noFill/>
@@ -6627,7 +6627,7 @@
             <a:pPr>
               <a:defRPr sz="1700" b="1">
                 <a:solidFill>
-                  <a:srgbClr val="58D6BD"/>
+                  <a:srgbClr val="007A8A"/>
                 </a:solidFill>
                 <a:latin typeface="맑은 고딕"/>
               </a:defRPr>
@@ -6663,7 +6663,7 @@
             <a:pPr>
               <a:defRPr sz="1800" b="0">
                 <a:solidFill>
-                  <a:srgbClr val="F3F6FA"/>
+                  <a:srgbClr val="16343B"/>
                 </a:solidFill>
                 <a:latin typeface="맑은 고딕"/>
               </a:defRPr>
@@ -6676,7 +6676,7 @@
       </p:sp>
       <p:sp>
         <p:nvSpPr>
-          <p:cNvPr id="13" name="Rectangle 12"/>
+          <p:cNvPr id="13" name="Rounded Rectangle 12"/>
           <p:cNvSpPr/>
           <p:nvPr/>
         </p:nvSpPr>
@@ -6685,11 +6685,11 @@
             <a:off x="4325112" y="3182112"/>
             <a:ext cx="3529584" cy="2194560"/>
           </a:xfrm>
-          <a:prstGeom prst="rect">
+          <a:prstGeom prst="roundRect">
             <a:avLst/>
           </a:prstGeom>
           <a:solidFill>
-            <a:srgbClr val="1A2A40"/>
+            <a:srgbClr val="EAF7F9"/>
           </a:solidFill>
           <a:ln>
             <a:noFill/>
@@ -6732,7 +6732,7 @@
             <a:avLst/>
           </a:prstGeom>
           <a:solidFill>
-            <a:srgbClr val="58D6BD"/>
+            <a:srgbClr val="007A8A"/>
           </a:solidFill>
           <a:ln>
             <a:noFill/>
@@ -6775,7 +6775,7 @@
             <a:avLst/>
           </a:prstGeom>
           <a:solidFill>
-            <a:srgbClr val="58D6BD"/>
+            <a:srgbClr val="007A8A"/>
           </a:solidFill>
           <a:ln>
             <a:noFill/>
@@ -6828,7 +6828,7 @@
             <a:pPr>
               <a:defRPr sz="1700" b="1">
                 <a:solidFill>
-                  <a:srgbClr val="58D6BD"/>
+                  <a:srgbClr val="007A8A"/>
                 </a:solidFill>
                 <a:latin typeface="맑은 고딕"/>
               </a:defRPr>
@@ -6864,7 +6864,7 @@
             <a:pPr>
               <a:defRPr sz="1800" b="0">
                 <a:solidFill>
-                  <a:srgbClr val="F3F6FA"/>
+                  <a:srgbClr val="16343B"/>
                 </a:solidFill>
                 <a:latin typeface="맑은 고딕"/>
               </a:defRPr>
@@ -6877,7 +6877,7 @@
       </p:sp>
       <p:sp>
         <p:nvSpPr>
-          <p:cNvPr id="18" name="Rectangle 17"/>
+          <p:cNvPr id="18" name="Rounded Rectangle 17"/>
           <p:cNvSpPr/>
           <p:nvPr/>
         </p:nvSpPr>
@@ -6886,11 +6886,11 @@
             <a:off x="8010144" y="3182112"/>
             <a:ext cx="3529584" cy="2194560"/>
           </a:xfrm>
-          <a:prstGeom prst="rect">
+          <a:prstGeom prst="roundRect">
             <a:avLst/>
           </a:prstGeom>
           <a:solidFill>
-            <a:srgbClr val="1A2A40"/>
+            <a:srgbClr val="EAF7F9"/>
           </a:solidFill>
           <a:ln>
             <a:noFill/>
@@ -6933,7 +6933,7 @@
             <a:avLst/>
           </a:prstGeom>
           <a:solidFill>
-            <a:srgbClr val="58D6BD"/>
+            <a:srgbClr val="007A8A"/>
           </a:solidFill>
           <a:ln>
             <a:noFill/>
@@ -6976,7 +6976,7 @@
             <a:avLst/>
           </a:prstGeom>
           <a:solidFill>
-            <a:srgbClr val="58D6BD"/>
+            <a:srgbClr val="007A8A"/>
           </a:solidFill>
           <a:ln>
             <a:noFill/>
@@ -7029,7 +7029,7 @@
             <a:pPr>
               <a:defRPr sz="1700" b="1">
                 <a:solidFill>
-                  <a:srgbClr val="58D6BD"/>
+                  <a:srgbClr val="007A8A"/>
                 </a:solidFill>
                 <a:latin typeface="맑은 고딕"/>
               </a:defRPr>
@@ -7065,7 +7065,7 @@
             <a:pPr>
               <a:defRPr sz="1800" b="0">
                 <a:solidFill>
-                  <a:srgbClr val="F3F6FA"/>
+                  <a:srgbClr val="16343B"/>
                 </a:solidFill>
                 <a:latin typeface="맑은 고딕"/>
               </a:defRPr>
@@ -7101,7 +7101,7 @@
             <a:pPr>
               <a:defRPr sz="1200" b="0">
                 <a:solidFill>
-                  <a:srgbClr val="A9BAD0"/>
+                  <a:srgbClr val="5C747B"/>
                 </a:solidFill>
                 <a:latin typeface="맑은 고딕"/>
               </a:defRPr>
@@ -7127,7 +7127,7 @@
             <a:avLst/>
           </a:prstGeom>
           <a:solidFill>
-            <a:srgbClr val="1A2A40"/>
+            <a:srgbClr val="EAF7F9"/>
           </a:solidFill>
           <a:ln>
             <a:noFill/>
@@ -7170,7 +7170,7 @@
             <a:avLst/>
           </a:prstGeom>
           <a:solidFill>
-            <a:srgbClr val="58D6BD"/>
+            <a:srgbClr val="007A8A"/>
           </a:solidFill>
           <a:ln>
             <a:noFill/>
@@ -7223,7 +7223,7 @@
             <a:pPr>
               <a:defRPr sz="900" b="0">
                 <a:solidFill>
-                  <a:srgbClr val="A9BAD0"/>
+                  <a:srgbClr val="5C747B"/>
                 </a:solidFill>
                 <a:latin typeface="맑은 고딕"/>
               </a:defRPr>
@@ -7259,7 +7259,7 @@
             <a:pPr>
               <a:defRPr sz="1000" b="0">
                 <a:solidFill>
-                  <a:srgbClr val="A9BAD0"/>
+                  <a:srgbClr val="5C747B"/>
                 </a:solidFill>
                 <a:latin typeface="맑은 고딕"/>
               </a:defRPr>
@@ -7303,7 +7303,7 @@
             <a:avLst/>
           </a:prstGeom>
           <a:solidFill>
-            <a:srgbClr val="101B2D"/>
+            <a:srgbClr val="FFFFFF"/>
           </a:solidFill>
           <a:ln>
             <a:noFill/>
@@ -7346,7 +7346,7 @@
             <a:avLst/>
           </a:prstGeom>
           <a:solidFill>
-            <a:srgbClr val="58D6BD"/>
+            <a:srgbClr val="007A8A"/>
           </a:solidFill>
           <a:ln>
             <a:noFill/>
@@ -7399,7 +7399,7 @@
             <a:pPr>
               <a:defRPr sz="1200" b="1">
                 <a:solidFill>
-                  <a:srgbClr val="58D6BD"/>
+                  <a:srgbClr val="007A8A"/>
                 </a:solidFill>
                 <a:latin typeface="맑은 고딕"/>
               </a:defRPr>
@@ -7435,7 +7435,7 @@
             <a:pPr>
               <a:defRPr sz="1200" b="0">
                 <a:solidFill>
-                  <a:srgbClr val="A9BAD0"/>
+                  <a:srgbClr val="5C747B"/>
                 </a:solidFill>
                 <a:latin typeface="맑은 고딕"/>
               </a:defRPr>
@@ -7471,7 +7471,7 @@
             <a:pPr>
               <a:defRPr sz="3200" b="1">
                 <a:solidFill>
-                  <a:srgbClr val="F3F6FA"/>
+                  <a:srgbClr val="16343B"/>
                 </a:solidFill>
                 <a:latin typeface="맑은 고딕"/>
               </a:defRPr>
@@ -7507,7 +7507,7 @@
             <a:pPr>
               <a:defRPr sz="1900" b="0">
                 <a:solidFill>
-                  <a:srgbClr val="A9BAD0"/>
+                  <a:srgbClr val="5C747B"/>
                 </a:solidFill>
                 <a:latin typeface="맑은 고딕"/>
               </a:defRPr>
@@ -7520,7 +7520,7 @@
       </p:sp>
       <p:sp>
         <p:nvSpPr>
-          <p:cNvPr id="8" name="Rectangle 7"/>
+          <p:cNvPr id="8" name="Rounded Rectangle 7"/>
           <p:cNvSpPr/>
           <p:nvPr/>
         </p:nvSpPr>
@@ -7529,11 +7529,11 @@
             <a:off x="640080" y="3182112"/>
             <a:ext cx="3529584" cy="2194560"/>
           </a:xfrm>
-          <a:prstGeom prst="rect">
+          <a:prstGeom prst="roundRect">
             <a:avLst/>
           </a:prstGeom>
           <a:solidFill>
-            <a:srgbClr val="1A2A40"/>
+            <a:srgbClr val="EAF7F9"/>
           </a:solidFill>
           <a:ln>
             <a:noFill/>
@@ -7576,7 +7576,7 @@
             <a:avLst/>
           </a:prstGeom>
           <a:solidFill>
-            <a:srgbClr val="58D6BD"/>
+            <a:srgbClr val="007A8A"/>
           </a:solidFill>
           <a:ln>
             <a:noFill/>
@@ -7619,7 +7619,7 @@
             <a:avLst/>
           </a:prstGeom>
           <a:solidFill>
-            <a:srgbClr val="58D6BD"/>
+            <a:srgbClr val="007A8A"/>
           </a:solidFill>
           <a:ln>
             <a:noFill/>
@@ -7672,7 +7672,7 @@
             <a:pPr>
               <a:defRPr sz="1700" b="1">
                 <a:solidFill>
-                  <a:srgbClr val="58D6BD"/>
+                  <a:srgbClr val="007A8A"/>
                 </a:solidFill>
                 <a:latin typeface="맑은 고딕"/>
               </a:defRPr>
@@ -7708,7 +7708,7 @@
             <a:pPr>
               <a:defRPr sz="1800" b="0">
                 <a:solidFill>
-                  <a:srgbClr val="F3F6FA"/>
+                  <a:srgbClr val="16343B"/>
                 </a:solidFill>
                 <a:latin typeface="맑은 고딕"/>
               </a:defRPr>
@@ -7721,7 +7721,7 @@
       </p:sp>
       <p:sp>
         <p:nvSpPr>
-          <p:cNvPr id="13" name="Rectangle 12"/>
+          <p:cNvPr id="13" name="Rounded Rectangle 12"/>
           <p:cNvSpPr/>
           <p:nvPr/>
         </p:nvSpPr>
@@ -7730,11 +7730,11 @@
             <a:off x="4325112" y="3182112"/>
             <a:ext cx="3529584" cy="2194560"/>
           </a:xfrm>
-          <a:prstGeom prst="rect">
+          <a:prstGeom prst="roundRect">
             <a:avLst/>
           </a:prstGeom>
           <a:solidFill>
-            <a:srgbClr val="1A2A40"/>
+            <a:srgbClr val="EAF7F9"/>
           </a:solidFill>
           <a:ln>
             <a:noFill/>
@@ -7777,7 +7777,7 @@
             <a:avLst/>
           </a:prstGeom>
           <a:solidFill>
-            <a:srgbClr val="58D6BD"/>
+            <a:srgbClr val="007A8A"/>
           </a:solidFill>
           <a:ln>
             <a:noFill/>
@@ -7820,7 +7820,7 @@
             <a:avLst/>
           </a:prstGeom>
           <a:solidFill>
-            <a:srgbClr val="58D6BD"/>
+            <a:srgbClr val="007A8A"/>
           </a:solidFill>
           <a:ln>
             <a:noFill/>
@@ -7873,7 +7873,7 @@
             <a:pPr>
               <a:defRPr sz="1700" b="1">
                 <a:solidFill>
-                  <a:srgbClr val="58D6BD"/>
+                  <a:srgbClr val="007A8A"/>
                 </a:solidFill>
                 <a:latin typeface="맑은 고딕"/>
               </a:defRPr>
@@ -7909,7 +7909,7 @@
             <a:pPr>
               <a:defRPr sz="1800" b="0">
                 <a:solidFill>
-                  <a:srgbClr val="F3F6FA"/>
+                  <a:srgbClr val="16343B"/>
                 </a:solidFill>
                 <a:latin typeface="맑은 고딕"/>
               </a:defRPr>
@@ -7922,7 +7922,7 @@
       </p:sp>
       <p:sp>
         <p:nvSpPr>
-          <p:cNvPr id="18" name="Rectangle 17"/>
+          <p:cNvPr id="18" name="Rounded Rectangle 17"/>
           <p:cNvSpPr/>
           <p:nvPr/>
         </p:nvSpPr>
@@ -7931,11 +7931,11 @@
             <a:off x="8010144" y="3182112"/>
             <a:ext cx="3529584" cy="2194560"/>
           </a:xfrm>
-          <a:prstGeom prst="rect">
+          <a:prstGeom prst="roundRect">
             <a:avLst/>
           </a:prstGeom>
           <a:solidFill>
-            <a:srgbClr val="1A2A40"/>
+            <a:srgbClr val="EAF7F9"/>
           </a:solidFill>
           <a:ln>
             <a:noFill/>
@@ -7978,7 +7978,7 @@
             <a:avLst/>
           </a:prstGeom>
           <a:solidFill>
-            <a:srgbClr val="58D6BD"/>
+            <a:srgbClr val="007A8A"/>
           </a:solidFill>
           <a:ln>
             <a:noFill/>
@@ -8021,7 +8021,7 @@
             <a:avLst/>
           </a:prstGeom>
           <a:solidFill>
-            <a:srgbClr val="58D6BD"/>
+            <a:srgbClr val="007A8A"/>
           </a:solidFill>
           <a:ln>
             <a:noFill/>
@@ -8074,7 +8074,7 @@
             <a:pPr>
               <a:defRPr sz="1700" b="1">
                 <a:solidFill>
-                  <a:srgbClr val="58D6BD"/>
+                  <a:srgbClr val="007A8A"/>
                 </a:solidFill>
                 <a:latin typeface="맑은 고딕"/>
               </a:defRPr>
@@ -8110,7 +8110,7 @@
             <a:pPr>
               <a:defRPr sz="1800" b="0">
                 <a:solidFill>
-                  <a:srgbClr val="F3F6FA"/>
+                  <a:srgbClr val="16343B"/>
                 </a:solidFill>
                 <a:latin typeface="맑은 고딕"/>
               </a:defRPr>
@@ -8123,7 +8123,7 @@
             <a:pPr>
               <a:defRPr sz="1800" b="0">
                 <a:solidFill>
-                  <a:srgbClr val="F3F6FA"/>
+                  <a:srgbClr val="16343B"/>
                 </a:solidFill>
                 <a:latin typeface="맑은 고딕"/>
               </a:defRPr>
@@ -8159,7 +8159,7 @@
             <a:pPr>
               <a:defRPr sz="1200" b="0">
                 <a:solidFill>
-                  <a:srgbClr val="A9BAD0"/>
+                  <a:srgbClr val="5C747B"/>
                 </a:solidFill>
                 <a:latin typeface="맑은 고딕"/>
               </a:defRPr>
@@ -8185,7 +8185,7 @@
             <a:avLst/>
           </a:prstGeom>
           <a:solidFill>
-            <a:srgbClr val="1A2A40"/>
+            <a:srgbClr val="EAF7F9"/>
           </a:solidFill>
           <a:ln>
             <a:noFill/>
@@ -8228,7 +8228,7 @@
             <a:avLst/>
           </a:prstGeom>
           <a:solidFill>
-            <a:srgbClr val="58D6BD"/>
+            <a:srgbClr val="007A8A"/>
           </a:solidFill>
           <a:ln>
             <a:noFill/>
@@ -8281,7 +8281,7 @@
             <a:pPr>
               <a:defRPr sz="900" b="0">
                 <a:solidFill>
-                  <a:srgbClr val="A9BAD0"/>
+                  <a:srgbClr val="5C747B"/>
                 </a:solidFill>
                 <a:latin typeface="맑은 고딕"/>
               </a:defRPr>
@@ -8317,7 +8317,7 @@
             <a:pPr>
               <a:defRPr sz="1000" b="0">
                 <a:solidFill>
-                  <a:srgbClr val="A9BAD0"/>
+                  <a:srgbClr val="5C747B"/>
                 </a:solidFill>
                 <a:latin typeface="맑은 고딕"/>
               </a:defRPr>
@@ -8361,7 +8361,7 @@
             <a:avLst/>
           </a:prstGeom>
           <a:solidFill>
-            <a:srgbClr val="101B2D"/>
+            <a:srgbClr val="FFFFFF"/>
           </a:solidFill>
           <a:ln>
             <a:noFill/>
@@ -8404,7 +8404,7 @@
             <a:avLst/>
           </a:prstGeom>
           <a:solidFill>
-            <a:srgbClr val="58D6BD"/>
+            <a:srgbClr val="007A8A"/>
           </a:solidFill>
           <a:ln>
             <a:noFill/>
@@ -8457,7 +8457,7 @@
             <a:pPr>
               <a:defRPr sz="1200" b="1">
                 <a:solidFill>
-                  <a:srgbClr val="58D6BD"/>
+                  <a:srgbClr val="007A8A"/>
                 </a:solidFill>
                 <a:latin typeface="맑은 고딕"/>
               </a:defRPr>
@@ -8493,7 +8493,7 @@
             <a:pPr>
               <a:defRPr sz="1200" b="0">
                 <a:solidFill>
-                  <a:srgbClr val="A9BAD0"/>
+                  <a:srgbClr val="5C747B"/>
                 </a:solidFill>
                 <a:latin typeface="맑은 고딕"/>
               </a:defRPr>
@@ -8529,7 +8529,7 @@
             <a:pPr>
               <a:defRPr sz="3200" b="1">
                 <a:solidFill>
-                  <a:srgbClr val="F3F6FA"/>
+                  <a:srgbClr val="16343B"/>
                 </a:solidFill>
                 <a:latin typeface="맑은 고딕"/>
               </a:defRPr>
@@ -8565,7 +8565,7 @@
             <a:pPr>
               <a:defRPr sz="1900" b="0">
                 <a:solidFill>
-                  <a:srgbClr val="A9BAD0"/>
+                  <a:srgbClr val="5C747B"/>
                 </a:solidFill>
                 <a:latin typeface="맑은 고딕"/>
               </a:defRPr>
@@ -8578,7 +8578,7 @@
       </p:sp>
       <p:sp>
         <p:nvSpPr>
-          <p:cNvPr id="8" name="Rectangle 7"/>
+          <p:cNvPr id="8" name="Rounded Rectangle 7"/>
           <p:cNvSpPr/>
           <p:nvPr/>
         </p:nvSpPr>
@@ -8587,11 +8587,11 @@
             <a:off x="640080" y="3182112"/>
             <a:ext cx="3529584" cy="2194560"/>
           </a:xfrm>
-          <a:prstGeom prst="rect">
+          <a:prstGeom prst="roundRect">
             <a:avLst/>
           </a:prstGeom>
           <a:solidFill>
-            <a:srgbClr val="1A2A40"/>
+            <a:srgbClr val="EAF7F9"/>
           </a:solidFill>
           <a:ln>
             <a:noFill/>
@@ -8634,7 +8634,7 @@
             <a:avLst/>
           </a:prstGeom>
           <a:solidFill>
-            <a:srgbClr val="58D6BD"/>
+            <a:srgbClr val="007A8A"/>
           </a:solidFill>
           <a:ln>
             <a:noFill/>
@@ -8677,7 +8677,7 @@
             <a:avLst/>
           </a:prstGeom>
           <a:solidFill>
-            <a:srgbClr val="58D6BD"/>
+            <a:srgbClr val="007A8A"/>
           </a:solidFill>
           <a:ln>
             <a:noFill/>
@@ -8730,7 +8730,7 @@
             <a:pPr>
               <a:defRPr sz="1700" b="1">
                 <a:solidFill>
-                  <a:srgbClr val="58D6BD"/>
+                  <a:srgbClr val="007A8A"/>
                 </a:solidFill>
                 <a:latin typeface="맑은 고딕"/>
               </a:defRPr>
@@ -8766,7 +8766,7 @@
             <a:pPr>
               <a:defRPr sz="1800" b="0">
                 <a:solidFill>
-                  <a:srgbClr val="F3F6FA"/>
+                  <a:srgbClr val="16343B"/>
                 </a:solidFill>
                 <a:latin typeface="맑은 고딕"/>
               </a:defRPr>
@@ -8779,7 +8779,7 @@
       </p:sp>
       <p:sp>
         <p:nvSpPr>
-          <p:cNvPr id="13" name="Rectangle 12"/>
+          <p:cNvPr id="13" name="Rounded Rectangle 12"/>
           <p:cNvSpPr/>
           <p:nvPr/>
         </p:nvSpPr>
@@ -8788,11 +8788,11 @@
             <a:off x="4325112" y="3182112"/>
             <a:ext cx="3529584" cy="2194560"/>
           </a:xfrm>
-          <a:prstGeom prst="rect">
+          <a:prstGeom prst="roundRect">
             <a:avLst/>
           </a:prstGeom>
           <a:solidFill>
-            <a:srgbClr val="1A2A40"/>
+            <a:srgbClr val="EAF7F9"/>
           </a:solidFill>
           <a:ln>
             <a:noFill/>
@@ -8835,7 +8835,7 @@
             <a:avLst/>
           </a:prstGeom>
           <a:solidFill>
-            <a:srgbClr val="58D6BD"/>
+            <a:srgbClr val="007A8A"/>
           </a:solidFill>
           <a:ln>
             <a:noFill/>
@@ -8878,7 +8878,7 @@
             <a:avLst/>
           </a:prstGeom>
           <a:solidFill>
-            <a:srgbClr val="58D6BD"/>
+            <a:srgbClr val="007A8A"/>
           </a:solidFill>
           <a:ln>
             <a:noFill/>
@@ -8931,7 +8931,7 @@
             <a:pPr>
               <a:defRPr sz="1700" b="1">
                 <a:solidFill>
-                  <a:srgbClr val="58D6BD"/>
+                  <a:srgbClr val="007A8A"/>
                 </a:solidFill>
                 <a:latin typeface="맑은 고딕"/>
               </a:defRPr>
@@ -8967,7 +8967,7 @@
             <a:pPr>
               <a:defRPr sz="1800" b="0">
                 <a:solidFill>
-                  <a:srgbClr val="F3F6FA"/>
+                  <a:srgbClr val="16343B"/>
                 </a:solidFill>
                 <a:latin typeface="맑은 고딕"/>
               </a:defRPr>
@@ -8980,7 +8980,7 @@
       </p:sp>
       <p:sp>
         <p:nvSpPr>
-          <p:cNvPr id="18" name="Rectangle 17"/>
+          <p:cNvPr id="18" name="Rounded Rectangle 17"/>
           <p:cNvSpPr/>
           <p:nvPr/>
         </p:nvSpPr>
@@ -8989,11 +8989,11 @@
             <a:off x="8010144" y="3182112"/>
             <a:ext cx="3529584" cy="2194560"/>
           </a:xfrm>
-          <a:prstGeom prst="rect">
+          <a:prstGeom prst="roundRect">
             <a:avLst/>
           </a:prstGeom>
           <a:solidFill>
-            <a:srgbClr val="1A2A40"/>
+            <a:srgbClr val="EAF7F9"/>
           </a:solidFill>
           <a:ln>
             <a:noFill/>
@@ -9036,7 +9036,7 @@
             <a:avLst/>
           </a:prstGeom>
           <a:solidFill>
-            <a:srgbClr val="58D6BD"/>
+            <a:srgbClr val="007A8A"/>
           </a:solidFill>
           <a:ln>
             <a:noFill/>
@@ -9079,7 +9079,7 @@
             <a:avLst/>
           </a:prstGeom>
           <a:solidFill>
-            <a:srgbClr val="58D6BD"/>
+            <a:srgbClr val="007A8A"/>
           </a:solidFill>
           <a:ln>
             <a:noFill/>
@@ -9132,7 +9132,7 @@
             <a:pPr>
               <a:defRPr sz="1700" b="1">
                 <a:solidFill>
-                  <a:srgbClr val="58D6BD"/>
+                  <a:srgbClr val="007A8A"/>
                 </a:solidFill>
                 <a:latin typeface="맑은 고딕"/>
               </a:defRPr>
@@ -9168,7 +9168,7 @@
             <a:pPr>
               <a:defRPr sz="1800" b="0">
                 <a:solidFill>
-                  <a:srgbClr val="F3F6FA"/>
+                  <a:srgbClr val="16343B"/>
                 </a:solidFill>
                 <a:latin typeface="맑은 고딕"/>
               </a:defRPr>
@@ -9194,7 +9194,7 @@
             <a:avLst/>
           </a:prstGeom>
           <a:solidFill>
-            <a:srgbClr val="101B2D"/>
+            <a:srgbClr val="FFFFFF"/>
           </a:solidFill>
           <a:ln>
             <a:noFill/>
@@ -9247,7 +9247,7 @@
             <a:pPr>
               <a:defRPr sz="2300" b="1">
                 <a:solidFill>
-                  <a:srgbClr val="58D6BD"/>
+                  <a:srgbClr val="007A8A"/>
                 </a:solidFill>
                 <a:latin typeface="맑은 고딕"/>
               </a:defRPr>
@@ -9273,7 +9273,7 @@
             <a:avLst/>
           </a:prstGeom>
           <a:solidFill>
-            <a:srgbClr val="101B2D"/>
+            <a:srgbClr val="FFFFFF"/>
           </a:solidFill>
           <a:ln>
             <a:noFill/>
@@ -9326,7 +9326,7 @@
             <a:pPr>
               <a:defRPr sz="2300" b="1">
                 <a:solidFill>
-                  <a:srgbClr val="58D6BD"/>
+                  <a:srgbClr val="007A8A"/>
                 </a:solidFill>
                 <a:latin typeface="맑은 고딕"/>
               </a:defRPr>
@@ -9362,7 +9362,7 @@
             <a:pPr>
               <a:defRPr sz="1200" b="0">
                 <a:solidFill>
-                  <a:srgbClr val="A9BAD0"/>
+                  <a:srgbClr val="5C747B"/>
                 </a:solidFill>
                 <a:latin typeface="맑은 고딕"/>
               </a:defRPr>
@@ -9388,7 +9388,7 @@
             <a:avLst/>
           </a:prstGeom>
           <a:solidFill>
-            <a:srgbClr val="1A2A40"/>
+            <a:srgbClr val="EAF7F9"/>
           </a:solidFill>
           <a:ln>
             <a:noFill/>
@@ -9431,7 +9431,7 @@
             <a:avLst/>
           </a:prstGeom>
           <a:solidFill>
-            <a:srgbClr val="58D6BD"/>
+            <a:srgbClr val="007A8A"/>
           </a:solidFill>
           <a:ln>
             <a:noFill/>
@@ -9484,7 +9484,7 @@
             <a:pPr>
               <a:defRPr sz="900" b="0">
                 <a:solidFill>
-                  <a:srgbClr val="A9BAD0"/>
+                  <a:srgbClr val="5C747B"/>
                 </a:solidFill>
                 <a:latin typeface="맑은 고딕"/>
               </a:defRPr>
@@ -9520,7 +9520,7 @@
             <a:pPr>
               <a:defRPr sz="1000" b="0">
                 <a:solidFill>
-                  <a:srgbClr val="A9BAD0"/>
+                  <a:srgbClr val="5C747B"/>
                 </a:solidFill>
                 <a:latin typeface="맑은 고딕"/>
               </a:defRPr>
@@ -9564,7 +9564,7 @@
             <a:avLst/>
           </a:prstGeom>
           <a:solidFill>
-            <a:srgbClr val="101B2D"/>
+            <a:srgbClr val="FFFFFF"/>
           </a:solidFill>
           <a:ln>
             <a:noFill/>
@@ -9607,7 +9607,7 @@
             <a:avLst/>
           </a:prstGeom>
           <a:solidFill>
-            <a:srgbClr val="58D6BD"/>
+            <a:srgbClr val="007A8A"/>
           </a:solidFill>
           <a:ln>
             <a:noFill/>
@@ -9660,7 +9660,7 @@
             <a:pPr>
               <a:defRPr sz="1200" b="1">
                 <a:solidFill>
-                  <a:srgbClr val="58D6BD"/>
+                  <a:srgbClr val="007A8A"/>
                 </a:solidFill>
                 <a:latin typeface="맑은 고딕"/>
               </a:defRPr>
@@ -9696,7 +9696,7 @@
             <a:pPr>
               <a:defRPr sz="1200" b="0">
                 <a:solidFill>
-                  <a:srgbClr val="A9BAD0"/>
+                  <a:srgbClr val="5C747B"/>
                 </a:solidFill>
                 <a:latin typeface="맑은 고딕"/>
               </a:defRPr>
@@ -9732,7 +9732,7 @@
             <a:pPr>
               <a:defRPr sz="3200" b="1">
                 <a:solidFill>
-                  <a:srgbClr val="F3F6FA"/>
+                  <a:srgbClr val="16343B"/>
                 </a:solidFill>
                 <a:latin typeface="맑은 고딕"/>
               </a:defRPr>
@@ -9768,7 +9768,7 @@
             <a:pPr>
               <a:defRPr sz="1900" b="0">
                 <a:solidFill>
-                  <a:srgbClr val="A9BAD0"/>
+                  <a:srgbClr val="5C747B"/>
                 </a:solidFill>
                 <a:latin typeface="맑은 고딕"/>
               </a:defRPr>
@@ -9781,7 +9781,7 @@
       </p:sp>
       <p:sp>
         <p:nvSpPr>
-          <p:cNvPr id="8" name="Rectangle 7"/>
+          <p:cNvPr id="8" name="Rounded Rectangle 7"/>
           <p:cNvSpPr/>
           <p:nvPr/>
         </p:nvSpPr>
@@ -9790,11 +9790,11 @@
             <a:off x="640080" y="3182112"/>
             <a:ext cx="3529584" cy="2194560"/>
           </a:xfrm>
-          <a:prstGeom prst="rect">
+          <a:prstGeom prst="roundRect">
             <a:avLst/>
           </a:prstGeom>
           <a:solidFill>
-            <a:srgbClr val="1A2A40"/>
+            <a:srgbClr val="EAF7F9"/>
           </a:solidFill>
           <a:ln>
             <a:noFill/>
@@ -9837,7 +9837,7 @@
             <a:avLst/>
           </a:prstGeom>
           <a:solidFill>
-            <a:srgbClr val="58D6BD"/>
+            <a:srgbClr val="007A8A"/>
           </a:solidFill>
           <a:ln>
             <a:noFill/>
@@ -9880,7 +9880,7 @@
             <a:avLst/>
           </a:prstGeom>
           <a:solidFill>
-            <a:srgbClr val="58D6BD"/>
+            <a:srgbClr val="007A8A"/>
           </a:solidFill>
           <a:ln>
             <a:noFill/>
@@ -9933,7 +9933,7 @@
             <a:pPr>
               <a:defRPr sz="1700" b="1">
                 <a:solidFill>
-                  <a:srgbClr val="58D6BD"/>
+                  <a:srgbClr val="007A8A"/>
                 </a:solidFill>
                 <a:latin typeface="맑은 고딕"/>
               </a:defRPr>
@@ -9969,7 +9969,7 @@
             <a:pPr>
               <a:defRPr sz="1800" b="0">
                 <a:solidFill>
-                  <a:srgbClr val="F3F6FA"/>
+                  <a:srgbClr val="16343B"/>
                 </a:solidFill>
                 <a:latin typeface="맑은 고딕"/>
               </a:defRPr>
@@ -9982,7 +9982,7 @@
             <a:pPr>
               <a:defRPr sz="1800" b="0">
                 <a:solidFill>
-                  <a:srgbClr val="F3F6FA"/>
+                  <a:srgbClr val="16343B"/>
                 </a:solidFill>
                 <a:latin typeface="맑은 고딕"/>
               </a:defRPr>
@@ -9995,7 +9995,7 @@
       </p:sp>
       <p:sp>
         <p:nvSpPr>
-          <p:cNvPr id="13" name="Rectangle 12"/>
+          <p:cNvPr id="13" name="Rounded Rectangle 12"/>
           <p:cNvSpPr/>
           <p:nvPr/>
         </p:nvSpPr>
@@ -10004,11 +10004,11 @@
             <a:off x="4325112" y="3182112"/>
             <a:ext cx="3529584" cy="2194560"/>
           </a:xfrm>
-          <a:prstGeom prst="rect">
+          <a:prstGeom prst="roundRect">
             <a:avLst/>
           </a:prstGeom>
           <a:solidFill>
-            <a:srgbClr val="1A2A40"/>
+            <a:srgbClr val="EAF7F9"/>
           </a:solidFill>
           <a:ln>
             <a:noFill/>
@@ -10051,7 +10051,7 @@
             <a:avLst/>
           </a:prstGeom>
           <a:solidFill>
-            <a:srgbClr val="58D6BD"/>
+            <a:srgbClr val="007A8A"/>
           </a:solidFill>
           <a:ln>
             <a:noFill/>
@@ -10094,7 +10094,7 @@
             <a:avLst/>
           </a:prstGeom>
           <a:solidFill>
-            <a:srgbClr val="FFBD69"/>
+            <a:srgbClr val="AC4A18"/>
           </a:solidFill>
           <a:ln>
             <a:noFill/>
@@ -10147,7 +10147,7 @@
             <a:pPr>
               <a:defRPr sz="1700" b="1">
                 <a:solidFill>
-                  <a:srgbClr val="FFBD69"/>
+                  <a:srgbClr val="AC4A18"/>
                 </a:solidFill>
                 <a:latin typeface="맑은 고딕"/>
               </a:defRPr>
@@ -10183,7 +10183,7 @@
             <a:pPr>
               <a:defRPr sz="1800" b="0">
                 <a:solidFill>
-                  <a:srgbClr val="F3F6FA"/>
+                  <a:srgbClr val="16343B"/>
                 </a:solidFill>
                 <a:latin typeface="맑은 고딕"/>
               </a:defRPr>
@@ -10196,7 +10196,7 @@
       </p:sp>
       <p:sp>
         <p:nvSpPr>
-          <p:cNvPr id="18" name="Rectangle 17"/>
+          <p:cNvPr id="18" name="Rounded Rectangle 17"/>
           <p:cNvSpPr/>
           <p:nvPr/>
         </p:nvSpPr>
@@ -10205,11 +10205,11 @@
             <a:off x="8010144" y="3182112"/>
             <a:ext cx="3529584" cy="2194560"/>
           </a:xfrm>
-          <a:prstGeom prst="rect">
+          <a:prstGeom prst="roundRect">
             <a:avLst/>
           </a:prstGeom>
           <a:solidFill>
-            <a:srgbClr val="1A2A40"/>
+            <a:srgbClr val="EAF7F9"/>
           </a:solidFill>
           <a:ln>
             <a:noFill/>
@@ -10252,7 +10252,7 @@
             <a:avLst/>
           </a:prstGeom>
           <a:solidFill>
-            <a:srgbClr val="58D6BD"/>
+            <a:srgbClr val="007A8A"/>
           </a:solidFill>
           <a:ln>
             <a:noFill/>
@@ -10295,7 +10295,7 @@
             <a:avLst/>
           </a:prstGeom>
           <a:solidFill>
-            <a:srgbClr val="BDABFF"/>
+            <a:srgbClr val="007A8A"/>
           </a:solidFill>
           <a:ln>
             <a:noFill/>
@@ -10348,7 +10348,7 @@
             <a:pPr>
               <a:defRPr sz="1700" b="1">
                 <a:solidFill>
-                  <a:srgbClr val="BDABFF"/>
+                  <a:srgbClr val="007A8A"/>
                 </a:solidFill>
                 <a:latin typeface="맑은 고딕"/>
               </a:defRPr>
@@ -10384,7 +10384,7 @@
             <a:pPr>
               <a:defRPr sz="1800" b="0">
                 <a:solidFill>
-                  <a:srgbClr val="F3F6FA"/>
+                  <a:srgbClr val="16343B"/>
                 </a:solidFill>
                 <a:latin typeface="맑은 고딕"/>
               </a:defRPr>
@@ -10397,7 +10397,7 @@
             <a:pPr>
               <a:defRPr sz="1800" b="0">
                 <a:solidFill>
-                  <a:srgbClr val="F3F6FA"/>
+                  <a:srgbClr val="16343B"/>
                 </a:solidFill>
                 <a:latin typeface="맑은 고딕"/>
               </a:defRPr>
@@ -10433,7 +10433,7 @@
             <a:pPr>
               <a:defRPr sz="1200" b="0">
                 <a:solidFill>
-                  <a:srgbClr val="A9BAD0"/>
+                  <a:srgbClr val="5C747B"/>
                 </a:solidFill>
                 <a:latin typeface="맑은 고딕"/>
               </a:defRPr>
@@ -10459,7 +10459,7 @@
             <a:avLst/>
           </a:prstGeom>
           <a:solidFill>
-            <a:srgbClr val="1A2A40"/>
+            <a:srgbClr val="EAF7F9"/>
           </a:solidFill>
           <a:ln>
             <a:noFill/>
@@ -10502,7 +10502,7 @@
             <a:avLst/>
           </a:prstGeom>
           <a:solidFill>
-            <a:srgbClr val="58D6BD"/>
+            <a:srgbClr val="007A8A"/>
           </a:solidFill>
           <a:ln>
             <a:noFill/>
@@ -10555,7 +10555,7 @@
             <a:pPr>
               <a:defRPr sz="900" b="0">
                 <a:solidFill>
-                  <a:srgbClr val="A9BAD0"/>
+                  <a:srgbClr val="5C747B"/>
                 </a:solidFill>
                 <a:latin typeface="맑은 고딕"/>
               </a:defRPr>
@@ -10591,7 +10591,7 @@
             <a:pPr>
               <a:defRPr sz="1000" b="0">
                 <a:solidFill>
-                  <a:srgbClr val="A9BAD0"/>
+                  <a:srgbClr val="5C747B"/>
                 </a:solidFill>
                 <a:latin typeface="맑은 고딕"/>
               </a:defRPr>
@@ -10635,7 +10635,7 @@
             <a:avLst/>
           </a:prstGeom>
           <a:solidFill>
-            <a:srgbClr val="101B2D"/>
+            <a:srgbClr val="FFFFFF"/>
           </a:solidFill>
           <a:ln>
             <a:noFill/>
@@ -10678,7 +10678,7 @@
             <a:avLst/>
           </a:prstGeom>
           <a:solidFill>
-            <a:srgbClr val="58D6BD"/>
+            <a:srgbClr val="007A8A"/>
           </a:solidFill>
           <a:ln>
             <a:noFill/>
@@ -10731,7 +10731,7 @@
             <a:pPr>
               <a:defRPr sz="1200" b="1">
                 <a:solidFill>
-                  <a:srgbClr val="58D6BD"/>
+                  <a:srgbClr val="007A8A"/>
                 </a:solidFill>
                 <a:latin typeface="맑은 고딕"/>
               </a:defRPr>
@@ -10767,7 +10767,7 @@
             <a:pPr>
               <a:defRPr sz="1200" b="0">
                 <a:solidFill>
-                  <a:srgbClr val="A9BAD0"/>
+                  <a:srgbClr val="5C747B"/>
                 </a:solidFill>
                 <a:latin typeface="맑은 고딕"/>
               </a:defRPr>
@@ -10803,7 +10803,7 @@
             <a:pPr>
               <a:defRPr sz="3200" b="1">
                 <a:solidFill>
-                  <a:srgbClr val="F3F6FA"/>
+                  <a:srgbClr val="16343B"/>
                 </a:solidFill>
                 <a:latin typeface="맑은 고딕"/>
               </a:defRPr>
@@ -10839,7 +10839,7 @@
             <a:pPr>
               <a:defRPr sz="1900" b="0">
                 <a:solidFill>
-                  <a:srgbClr val="A9BAD0"/>
+                  <a:srgbClr val="5C747B"/>
                 </a:solidFill>
                 <a:latin typeface="맑은 고딕"/>
               </a:defRPr>
@@ -10852,7 +10852,7 @@
       </p:sp>
       <p:sp>
         <p:nvSpPr>
-          <p:cNvPr id="8" name="Rectangle 7"/>
+          <p:cNvPr id="8" name="Rounded Rectangle 7"/>
           <p:cNvSpPr/>
           <p:nvPr/>
         </p:nvSpPr>
@@ -10861,11 +10861,11 @@
             <a:off x="640080" y="3182112"/>
             <a:ext cx="3529584" cy="2194560"/>
           </a:xfrm>
-          <a:prstGeom prst="rect">
+          <a:prstGeom prst="roundRect">
             <a:avLst/>
           </a:prstGeom>
           <a:solidFill>
-            <a:srgbClr val="1A2A40"/>
+            <a:srgbClr val="EAF7F9"/>
           </a:solidFill>
           <a:ln>
             <a:noFill/>
@@ -10908,7 +10908,7 @@
             <a:avLst/>
           </a:prstGeom>
           <a:solidFill>
-            <a:srgbClr val="58D6BD"/>
+            <a:srgbClr val="007A8A"/>
           </a:solidFill>
           <a:ln>
             <a:noFill/>
@@ -10951,7 +10951,7 @@
             <a:avLst/>
           </a:prstGeom>
           <a:solidFill>
-            <a:srgbClr val="58D6BD"/>
+            <a:srgbClr val="007A8A"/>
           </a:solidFill>
           <a:ln>
             <a:noFill/>
@@ -11004,7 +11004,7 @@
             <a:pPr>
               <a:defRPr sz="1700" b="1">
                 <a:solidFill>
-                  <a:srgbClr val="58D6BD"/>
+                  <a:srgbClr val="007A8A"/>
                 </a:solidFill>
                 <a:latin typeface="맑은 고딕"/>
               </a:defRPr>
@@ -11040,7 +11040,7 @@
             <a:pPr>
               <a:defRPr sz="1800" b="0">
                 <a:solidFill>
-                  <a:srgbClr val="F3F6FA"/>
+                  <a:srgbClr val="16343B"/>
                 </a:solidFill>
                 <a:latin typeface="맑은 고딕"/>
               </a:defRPr>
@@ -11053,7 +11053,7 @@
             <a:pPr>
               <a:defRPr sz="1800" b="0">
                 <a:solidFill>
-                  <a:srgbClr val="F3F6FA"/>
+                  <a:srgbClr val="16343B"/>
                 </a:solidFill>
                 <a:latin typeface="맑은 고딕"/>
               </a:defRPr>
@@ -11066,7 +11066,7 @@
       </p:sp>
       <p:sp>
         <p:nvSpPr>
-          <p:cNvPr id="13" name="Rectangle 12"/>
+          <p:cNvPr id="13" name="Rounded Rectangle 12"/>
           <p:cNvSpPr/>
           <p:nvPr/>
         </p:nvSpPr>
@@ -11075,11 +11075,11 @@
             <a:off x="4325112" y="3182112"/>
             <a:ext cx="3529584" cy="2194560"/>
           </a:xfrm>
-          <a:prstGeom prst="rect">
+          <a:prstGeom prst="roundRect">
             <a:avLst/>
           </a:prstGeom>
           <a:solidFill>
-            <a:srgbClr val="1A2A40"/>
+            <a:srgbClr val="EAF7F9"/>
           </a:solidFill>
           <a:ln>
             <a:noFill/>
@@ -11122,7 +11122,7 @@
             <a:avLst/>
           </a:prstGeom>
           <a:solidFill>
-            <a:srgbClr val="58D6BD"/>
+            <a:srgbClr val="007A8A"/>
           </a:solidFill>
           <a:ln>
             <a:noFill/>
@@ -11165,7 +11165,7 @@
             <a:avLst/>
           </a:prstGeom>
           <a:solidFill>
-            <a:srgbClr val="58D6BD"/>
+            <a:srgbClr val="007A8A"/>
           </a:solidFill>
           <a:ln>
             <a:noFill/>
@@ -11218,7 +11218,7 @@
             <a:pPr>
               <a:defRPr sz="1700" b="1">
                 <a:solidFill>
-                  <a:srgbClr val="58D6BD"/>
+                  <a:srgbClr val="007A8A"/>
                 </a:solidFill>
                 <a:latin typeface="맑은 고딕"/>
               </a:defRPr>
@@ -11254,7 +11254,7 @@
             <a:pPr>
               <a:defRPr sz="1800" b="0">
                 <a:solidFill>
-                  <a:srgbClr val="F3F6FA"/>
+                  <a:srgbClr val="16343B"/>
                 </a:solidFill>
                 <a:latin typeface="맑은 고딕"/>
               </a:defRPr>
@@ -11267,7 +11267,7 @@
             <a:pPr>
               <a:defRPr sz="1800" b="0">
                 <a:solidFill>
-                  <a:srgbClr val="F3F6FA"/>
+                  <a:srgbClr val="16343B"/>
                 </a:solidFill>
                 <a:latin typeface="맑은 고딕"/>
               </a:defRPr>
@@ -11280,7 +11280,7 @@
       </p:sp>
       <p:sp>
         <p:nvSpPr>
-          <p:cNvPr id="18" name="Rectangle 17"/>
+          <p:cNvPr id="18" name="Rounded Rectangle 17"/>
           <p:cNvSpPr/>
           <p:nvPr/>
         </p:nvSpPr>
@@ -11289,11 +11289,11 @@
             <a:off x="8010144" y="3182112"/>
             <a:ext cx="3529584" cy="2194560"/>
           </a:xfrm>
-          <a:prstGeom prst="rect">
+          <a:prstGeom prst="roundRect">
             <a:avLst/>
           </a:prstGeom>
           <a:solidFill>
-            <a:srgbClr val="1A2A40"/>
+            <a:srgbClr val="EAF7F9"/>
           </a:solidFill>
           <a:ln>
             <a:noFill/>
@@ -11336,7 +11336,7 @@
             <a:avLst/>
           </a:prstGeom>
           <a:solidFill>
-            <a:srgbClr val="58D6BD"/>
+            <a:srgbClr val="007A8A"/>
           </a:solidFill>
           <a:ln>
             <a:noFill/>
@@ -11379,7 +11379,7 @@
             <a:avLst/>
           </a:prstGeom>
           <a:solidFill>
-            <a:srgbClr val="58D6BD"/>
+            <a:srgbClr val="007A8A"/>
           </a:solidFill>
           <a:ln>
             <a:noFill/>
@@ -11432,7 +11432,7 @@
             <a:pPr>
               <a:defRPr sz="1700" b="1">
                 <a:solidFill>
-                  <a:srgbClr val="58D6BD"/>
+                  <a:srgbClr val="007A8A"/>
                 </a:solidFill>
                 <a:latin typeface="맑은 고딕"/>
               </a:defRPr>
@@ -11468,7 +11468,7 @@
             <a:pPr>
               <a:defRPr sz="1800" b="0">
                 <a:solidFill>
-                  <a:srgbClr val="F3F6FA"/>
+                  <a:srgbClr val="16343B"/>
                 </a:solidFill>
                 <a:latin typeface="맑은 고딕"/>
               </a:defRPr>
@@ -11481,7 +11481,7 @@
             <a:pPr>
               <a:defRPr sz="1800" b="0">
                 <a:solidFill>
-                  <a:srgbClr val="F3F6FA"/>
+                  <a:srgbClr val="16343B"/>
                 </a:solidFill>
                 <a:latin typeface="맑은 고딕"/>
               </a:defRPr>
@@ -11517,7 +11517,7 @@
             <a:pPr>
               <a:defRPr sz="1200" b="0">
                 <a:solidFill>
-                  <a:srgbClr val="A9BAD0"/>
+                  <a:srgbClr val="5C747B"/>
                 </a:solidFill>
                 <a:latin typeface="맑은 고딕"/>
               </a:defRPr>
@@ -11543,7 +11543,7 @@
             <a:avLst/>
           </a:prstGeom>
           <a:solidFill>
-            <a:srgbClr val="1A2A40"/>
+            <a:srgbClr val="EAF7F9"/>
           </a:solidFill>
           <a:ln>
             <a:noFill/>
@@ -11586,7 +11586,7 @@
             <a:avLst/>
           </a:prstGeom>
           <a:solidFill>
-            <a:srgbClr val="58D6BD"/>
+            <a:srgbClr val="007A8A"/>
           </a:solidFill>
           <a:ln>
             <a:noFill/>
@@ -11639,7 +11639,7 @@
             <a:pPr>
               <a:defRPr sz="900" b="0">
                 <a:solidFill>
-                  <a:srgbClr val="A9BAD0"/>
+                  <a:srgbClr val="5C747B"/>
                 </a:solidFill>
                 <a:latin typeface="맑은 고딕"/>
               </a:defRPr>
@@ -11675,7 +11675,7 @@
             <a:pPr>
               <a:defRPr sz="1000" b="0">
                 <a:solidFill>
-                  <a:srgbClr val="A9BAD0"/>
+                  <a:srgbClr val="5C747B"/>
                 </a:solidFill>
                 <a:latin typeface="맑은 고딕"/>
               </a:defRPr>

</xml_diff>

<commit_message>
Center workshop demo on credential approval and revocation
</commit_message>
<xml_diff>
--- a/video/Video_Slides.pptx
+++ b/video/Video_Slides.pptx
@@ -7477,7 +7477,7 @@
               </a:defRPr>
             </a:pPr>
             <a:r>
-              <a:t>false 증명도 지급이 통과했습니다</a:t>
+              <a:t>승인 취소가 다음 지급을 막습니다</a:t>
             </a:r>
           </a:p>
         </p:txBody>
@@ -7513,7 +7513,7 @@
               </a:defRPr>
             </a:pPr>
             <a:r>
-              <a:t>온체인 데이터와 실제 거래 결과를 비교</a:t>
+              <a:t>기존 증명을 폐기한 뒤 같은 지급 요청을 비교</a:t>
             </a:r>
           </a:p>
         </p:txBody>
@@ -7678,7 +7678,7 @@
               </a:defRPr>
             </a:pPr>
             <a:r>
-              <a:t>false</a:t>
+              <a:t>폐기</a:t>
             </a:r>
           </a:p>
         </p:txBody>
@@ -7714,7 +7714,7 @@
               </a:defRPr>
             </a:pPr>
             <a:r>
-              <a:t>성공</a:t>
+              <a:t>기존 자격 폐기</a:t>
             </a:r>
           </a:p>
         </p:txBody>
@@ -7879,7 +7879,7 @@
               </a:defRPr>
             </a:pPr>
             <a:r>
-              <a:t>true</a:t>
+              <a:t>거절</a:t>
             </a:r>
           </a:p>
         </p:txBody>
@@ -7915,7 +7915,20 @@
               </a:defRPr>
             </a:pPr>
             <a:r>
-              <a:t>성공</a:t>
+              <a:t>status 0</a:t>
+            </a:r>
+          </a:p>
+          <a:p>
+            <a:pPr>
+              <a:defRPr sz="1800" b="0">
+                <a:solidFill>
+                  <a:srgbClr val="16343B"/>
+                </a:solidFill>
+                <a:latin typeface="맑은 고딕"/>
+              </a:defRPr>
+            </a:pPr>
+            <a:r>
+              <a:t>EasAttestationRevoked</a:t>
             </a:r>
           </a:p>
         </p:txBody>
@@ -8080,7 +8093,7 @@
               </a:defRPr>
             </a:pPr>
             <a:r>
-              <a:t>설계 의미</a:t>
+              <a:t>확인</a:t>
             </a:r>
           </a:p>
         </p:txBody>
@@ -8116,7 +8129,7 @@
               </a:defRPr>
             </a:pPr>
             <a:r>
-              <a:t>승인 대상에게 발급</a:t>
+              <a:t>수취인 증가량 0</a:t>
             </a:r>
           </a:p>
           <a:p>
@@ -8129,7 +8142,7 @@
               </a:defRPr>
             </a:pPr>
             <a:r>
-              <a:t>취소 시 폐기</a:t>
+              <a:t>발급자 제한은 별도 설계</a:t>
             </a:r>
           </a:p>
         </p:txBody>

</xml_diff>